<commit_message>
update lab 7 and 8
</commit_message>
<xml_diff>
--- a/AIAndNN/spring2026/theory/lectures/lecture7.pptx
+++ b/AIAndNN/spring2026/theory/lectures/lecture7.pptx
@@ -5,7 +5,7 @@
     <p:sldMasterId id="2147483648" r:id="rId1"/>
   </p:sldMasterIdLst>
   <p:notesMasterIdLst>
-    <p:notesMasterId r:id="rId19"/>
+    <p:notesMasterId r:id="rId18"/>
   </p:notesMasterIdLst>
   <p:sldIdLst>
     <p:sldId id="256" r:id="rId2"/>
@@ -21,10 +21,9 @@
     <p:sldId id="301" r:id="rId12"/>
     <p:sldId id="302" r:id="rId13"/>
     <p:sldId id="303" r:id="rId14"/>
-    <p:sldId id="304" r:id="rId15"/>
-    <p:sldId id="305" r:id="rId16"/>
-    <p:sldId id="306" r:id="rId17"/>
-    <p:sldId id="307" r:id="rId18"/>
+    <p:sldId id="305" r:id="rId15"/>
+    <p:sldId id="306" r:id="rId16"/>
+    <p:sldId id="307" r:id="rId17"/>
   </p:sldIdLst>
   <p:sldSz cx="9144000" cy="6858000" type="screen4x3"/>
   <p:notesSz cx="6858000" cy="9144000"/>
@@ -224,7 +223,7 @@
           <a:p>
             <a:fld id="{3EDA5460-0223-4DAF-A138-9183965676CE}" type="datetimeFigureOut">
               <a:rPr lang="en-US" smtClean="0"/>
-              <a:t>1/16/2026</a:t>
+              <a:t>5/12/2026</a:t>
             </a:fld>
             <a:endParaRPr lang="en-US"/>
           </a:p>
@@ -670,7 +669,7 @@
           <a:p>
             <a:fld id="{5BCAD085-E8A6-8845-BD4E-CB4CCA059FC4}" type="datetimeFigureOut">
               <a:rPr lang="en-US" smtClean="0"/>
-              <a:t>1/16/2026</a:t>
+              <a:t>5/12/2026</a:t>
             </a:fld>
             <a:endParaRPr lang="en-US"/>
           </a:p>
@@ -838,7 +837,7 @@
           <a:p>
             <a:fld id="{5BCAD085-E8A6-8845-BD4E-CB4CCA059FC4}" type="datetimeFigureOut">
               <a:rPr lang="en-US" smtClean="0"/>
-              <a:t>1/16/2026</a:t>
+              <a:t>5/12/2026</a:t>
             </a:fld>
             <a:endParaRPr lang="en-US"/>
           </a:p>
@@ -1016,7 +1015,7 @@
           <a:p>
             <a:fld id="{5BCAD085-E8A6-8845-BD4E-CB4CCA059FC4}" type="datetimeFigureOut">
               <a:rPr lang="en-US" smtClean="0"/>
-              <a:t>1/16/2026</a:t>
+              <a:t>5/12/2026</a:t>
             </a:fld>
             <a:endParaRPr lang="en-US"/>
           </a:p>
@@ -1184,7 +1183,7 @@
           <a:p>
             <a:fld id="{5BCAD085-E8A6-8845-BD4E-CB4CCA059FC4}" type="datetimeFigureOut">
               <a:rPr lang="en-US" smtClean="0"/>
-              <a:t>1/16/2026</a:t>
+              <a:t>5/12/2026</a:t>
             </a:fld>
             <a:endParaRPr lang="en-US"/>
           </a:p>
@@ -1429,7 +1428,7 @@
           <a:p>
             <a:fld id="{5BCAD085-E8A6-8845-BD4E-CB4CCA059FC4}" type="datetimeFigureOut">
               <a:rPr lang="en-US" smtClean="0"/>
-              <a:t>1/16/2026</a:t>
+              <a:t>5/12/2026</a:t>
             </a:fld>
             <a:endParaRPr lang="en-US"/>
           </a:p>
@@ -1714,7 +1713,7 @@
           <a:p>
             <a:fld id="{5BCAD085-E8A6-8845-BD4E-CB4CCA059FC4}" type="datetimeFigureOut">
               <a:rPr lang="en-US" smtClean="0"/>
-              <a:t>1/16/2026</a:t>
+              <a:t>5/12/2026</a:t>
             </a:fld>
             <a:endParaRPr lang="en-US"/>
           </a:p>
@@ -2133,7 +2132,7 @@
           <a:p>
             <a:fld id="{5BCAD085-E8A6-8845-BD4E-CB4CCA059FC4}" type="datetimeFigureOut">
               <a:rPr lang="en-US" smtClean="0"/>
-              <a:t>1/16/2026</a:t>
+              <a:t>5/12/2026</a:t>
             </a:fld>
             <a:endParaRPr lang="en-US"/>
           </a:p>
@@ -2250,7 +2249,7 @@
           <a:p>
             <a:fld id="{5BCAD085-E8A6-8845-BD4E-CB4CCA059FC4}" type="datetimeFigureOut">
               <a:rPr lang="en-US" smtClean="0"/>
-              <a:t>1/16/2026</a:t>
+              <a:t>5/12/2026</a:t>
             </a:fld>
             <a:endParaRPr lang="en-US"/>
           </a:p>
@@ -2345,7 +2344,7 @@
           <a:p>
             <a:fld id="{5BCAD085-E8A6-8845-BD4E-CB4CCA059FC4}" type="datetimeFigureOut">
               <a:rPr lang="en-US" smtClean="0"/>
-              <a:t>1/16/2026</a:t>
+              <a:t>5/12/2026</a:t>
             </a:fld>
             <a:endParaRPr lang="en-US"/>
           </a:p>
@@ -2620,7 +2619,7 @@
           <a:p>
             <a:fld id="{5BCAD085-E8A6-8845-BD4E-CB4CCA059FC4}" type="datetimeFigureOut">
               <a:rPr lang="en-US" smtClean="0"/>
-              <a:t>1/16/2026</a:t>
+              <a:t>5/12/2026</a:t>
             </a:fld>
             <a:endParaRPr lang="en-US"/>
           </a:p>
@@ -2872,7 +2871,7 @@
           <a:p>
             <a:fld id="{5BCAD085-E8A6-8845-BD4E-CB4CCA059FC4}" type="datetimeFigureOut">
               <a:rPr lang="en-US" smtClean="0"/>
-              <a:t>1/16/2026</a:t>
+              <a:t>5/12/2026</a:t>
             </a:fld>
             <a:endParaRPr lang="en-US"/>
           </a:p>
@@ -3083,7 +3082,7 @@
           <a:p>
             <a:fld id="{5BCAD085-E8A6-8845-BD4E-CB4CCA059FC4}" type="datetimeFigureOut">
               <a:rPr lang="en-US" smtClean="0"/>
-              <a:t>1/16/2026</a:t>
+              <a:t>5/12/2026</a:t>
             </a:fld>
             <a:endParaRPr lang="en-US"/>
           </a:p>
@@ -4241,7 +4240,7 @@
           <p:cNvPr id="2" name="Title 1">
             <a:extLst>
               <a:ext uri="{FF2B5EF4-FFF2-40B4-BE49-F238E27FC236}">
-                <a16:creationId xmlns:a16="http://schemas.microsoft.com/office/drawing/2014/main" id="{1DC76F93-3826-7F68-FFEC-416B268E2A09}"/>
+                <a16:creationId xmlns:a16="http://schemas.microsoft.com/office/drawing/2014/main" id="{DA902C96-AB9C-63CC-5FB7-A21BB8B72B5B}"/>
               </a:ext>
             </a:extLst>
           </p:cNvPr>
@@ -4250,6 +4249,34 @@
           </p:cNvSpPr>
           <p:nvPr>
             <p:ph type="title"/>
+          </p:nvPr>
+        </p:nvSpPr>
+        <p:spPr/>
+        <p:txBody>
+          <a:bodyPr/>
+          <a:lstStyle/>
+          <a:p>
+            <a:r>
+              <a:rPr lang="en-US" dirty="0"/>
+              <a:t>Overfitting Concept</a:t>
+            </a:r>
+          </a:p>
+        </p:txBody>
+      </p:sp>
+      <p:sp>
+        <p:nvSpPr>
+          <p:cNvPr id="3" name="Content Placeholder 2">
+            <a:extLst>
+              <a:ext uri="{FF2B5EF4-FFF2-40B4-BE49-F238E27FC236}">
+                <a16:creationId xmlns:a16="http://schemas.microsoft.com/office/drawing/2014/main" id="{0981BFCB-4092-D87F-D44D-FA2126C75DCE}"/>
+              </a:ext>
+            </a:extLst>
+          </p:cNvPr>
+          <p:cNvSpPr>
+            <a:spLocks noGrp="1"/>
+          </p:cNvSpPr>
+          <p:nvPr>
+            <p:ph idx="1"/>
           </p:nvPr>
         </p:nvSpPr>
         <p:spPr/>
@@ -4259,75 +4286,89 @@
           </a:bodyPr>
           <a:lstStyle/>
           <a:p>
-            <a:r>
-              <a:rPr lang="en-US" sz="4000" dirty="0"/>
-              <a:t>Ideal Machine Learning Model</a:t>
-            </a:r>
-          </a:p>
-        </p:txBody>
-      </p:sp>
-      <p:sp>
-        <p:nvSpPr>
-          <p:cNvPr id="3" name="Content Placeholder 2">
-            <a:extLst>
-              <a:ext uri="{FF2B5EF4-FFF2-40B4-BE49-F238E27FC236}">
-                <a16:creationId xmlns:a16="http://schemas.microsoft.com/office/drawing/2014/main" id="{EF61F9D5-DA1D-3926-E52C-163AA4E5BED0}"/>
-              </a:ext>
-            </a:extLst>
-          </p:cNvPr>
-          <p:cNvSpPr>
-            <a:spLocks noGrp="1"/>
-          </p:cNvSpPr>
-          <p:nvPr>
-            <p:ph idx="1"/>
-          </p:nvPr>
-        </p:nvSpPr>
-        <p:spPr/>
-        <p:txBody>
-          <a:bodyPr>
-            <a:normAutofit/>
-          </a:bodyPr>
-          <a:lstStyle/>
-          <a:p>
             <a:pPr marL="0" indent="0">
               <a:buNone/>
             </a:pPr>
             <a:r>
               <a:rPr lang="en-US" sz="1800" b="1" dirty="0"/>
-              <a:t>An ideal model should have:</a:t>
-            </a:r>
-          </a:p>
-          <a:p>
-            <a:r>
-              <a:rPr lang="en-US" sz="1800" dirty="0"/>
-              <a:t>Low Training Error</a:t>
-            </a:r>
-          </a:p>
-          <a:p>
-            <a:r>
-              <a:rPr lang="en-US" sz="1800" dirty="0"/>
-              <a:t>Low Testing Error</a:t>
-            </a:r>
-          </a:p>
-          <a:p>
-            <a:pPr marL="0" indent="0">
-              <a:buNone/>
-            </a:pPr>
+              <a:t>Overfitting:</a:t>
+            </a:r>
+            <a:endParaRPr lang="en-US" sz="1800" dirty="0"/>
+          </a:p>
+          <a:p>
+            <a:r>
+              <a:rPr lang="en-US" sz="1800" dirty="0"/>
+              <a:t>Model learns training data </a:t>
+            </a:r>
             <a:r>
               <a:rPr lang="en-US" sz="1800" b="1" dirty="0"/>
-              <a:t>Means:</a:t>
-            </a:r>
-          </a:p>
-          <a:p>
-            <a:r>
-              <a:rPr lang="en-US" sz="1800" dirty="0"/>
-              <a:t>Model learned well</a:t>
-            </a:r>
-          </a:p>
-          <a:p>
-            <a:r>
-              <a:rPr lang="en-US" sz="1800" dirty="0"/>
-              <a:t>Model generalizes well</a:t>
+              <a:t>too perfectly</a:t>
+            </a:r>
+            <a:endParaRPr lang="en-US" sz="1800" dirty="0"/>
+          </a:p>
+          <a:p>
+            <a:r>
+              <a:rPr lang="en-US" sz="1800" dirty="0"/>
+              <a:t>Results:</a:t>
+            </a:r>
+          </a:p>
+          <a:p>
+            <a:r>
+              <a:rPr lang="en-US" sz="1800" dirty="0"/>
+              <a:t>Very low training error</a:t>
+            </a:r>
+          </a:p>
+          <a:p>
+            <a:r>
+              <a:rPr lang="en-US" sz="1800" dirty="0"/>
+              <a:t>Very high testing error</a:t>
+            </a:r>
+          </a:p>
+          <a:p>
+            <a:endParaRPr lang="en-US" sz="1800" dirty="0"/>
+          </a:p>
+          <a:p>
+            <a:r>
+              <a:rPr lang="en-US" sz="1800" b="1" dirty="0"/>
+              <a:t>Real-Life Example - Overfitting</a:t>
+            </a:r>
+          </a:p>
+          <a:p>
+            <a:r>
+              <a:rPr lang="en-US" sz="1800" dirty="0"/>
+              <a:t>A student:</a:t>
+            </a:r>
+          </a:p>
+          <a:p>
+            <a:r>
+              <a:rPr lang="en-US" sz="1800" dirty="0"/>
+              <a:t>Memorizes answers instead of understanding concepts</a:t>
+            </a:r>
+          </a:p>
+          <a:p>
+            <a:r>
+              <a:rPr lang="en-US" sz="1800" dirty="0"/>
+              <a:t>Scores 100% in practice tests</a:t>
+            </a:r>
+          </a:p>
+          <a:p>
+            <a:r>
+              <a:rPr lang="en-US" sz="1800" dirty="0"/>
+              <a:t>Fails final exam</a:t>
+            </a:r>
+          </a:p>
+          <a:p>
+            <a:r>
+              <a:rPr lang="en-US" sz="1800" dirty="0"/>
+              <a:t>This is </a:t>
+            </a:r>
+            <a:r>
+              <a:rPr lang="en-US" sz="1800" b="1" dirty="0"/>
+              <a:t>Overfitting</a:t>
+            </a:r>
+            <a:r>
+              <a:rPr lang="en-US" sz="1800" dirty="0"/>
+              <a:t>.</a:t>
             </a:r>
           </a:p>
           <a:p>
@@ -4338,7 +4379,7 @@
     </p:spTree>
     <p:extLst>
       <p:ext uri="{BB962C8B-B14F-4D97-AF65-F5344CB8AC3E}">
-        <p14:creationId xmlns:p14="http://schemas.microsoft.com/office/powerpoint/2010/main" val="1201852343"/>
+        <p14:creationId xmlns:p14="http://schemas.microsoft.com/office/powerpoint/2010/main" val="793153003"/>
       </p:ext>
     </p:extLst>
   </p:cSld>
@@ -4370,177 +4411,6 @@
           <p:cNvPr id="2" name="Title 1">
             <a:extLst>
               <a:ext uri="{FF2B5EF4-FFF2-40B4-BE49-F238E27FC236}">
-                <a16:creationId xmlns:a16="http://schemas.microsoft.com/office/drawing/2014/main" id="{DA902C96-AB9C-63CC-5FB7-A21BB8B72B5B}"/>
-              </a:ext>
-            </a:extLst>
-          </p:cNvPr>
-          <p:cNvSpPr>
-            <a:spLocks noGrp="1"/>
-          </p:cNvSpPr>
-          <p:nvPr>
-            <p:ph type="title"/>
-          </p:nvPr>
-        </p:nvSpPr>
-        <p:spPr/>
-        <p:txBody>
-          <a:bodyPr/>
-          <a:lstStyle/>
-          <a:p>
-            <a:r>
-              <a:rPr lang="en-US" dirty="0"/>
-              <a:t>Overfitting Concept</a:t>
-            </a:r>
-          </a:p>
-        </p:txBody>
-      </p:sp>
-      <p:sp>
-        <p:nvSpPr>
-          <p:cNvPr id="3" name="Content Placeholder 2">
-            <a:extLst>
-              <a:ext uri="{FF2B5EF4-FFF2-40B4-BE49-F238E27FC236}">
-                <a16:creationId xmlns:a16="http://schemas.microsoft.com/office/drawing/2014/main" id="{0981BFCB-4092-D87F-D44D-FA2126C75DCE}"/>
-              </a:ext>
-            </a:extLst>
-          </p:cNvPr>
-          <p:cNvSpPr>
-            <a:spLocks noGrp="1"/>
-          </p:cNvSpPr>
-          <p:nvPr>
-            <p:ph idx="1"/>
-          </p:nvPr>
-        </p:nvSpPr>
-        <p:spPr/>
-        <p:txBody>
-          <a:bodyPr>
-            <a:normAutofit/>
-          </a:bodyPr>
-          <a:lstStyle/>
-          <a:p>
-            <a:pPr marL="0" indent="0">
-              <a:buNone/>
-            </a:pPr>
-            <a:r>
-              <a:rPr lang="en-US" sz="1800" b="1" dirty="0"/>
-              <a:t>Overfitting:</a:t>
-            </a:r>
-            <a:endParaRPr lang="en-US" sz="1800" dirty="0"/>
-          </a:p>
-          <a:p>
-            <a:r>
-              <a:rPr lang="en-US" sz="1800" dirty="0"/>
-              <a:t>Model learns training data </a:t>
-            </a:r>
-            <a:r>
-              <a:rPr lang="en-US" sz="1800" b="1" dirty="0"/>
-              <a:t>too perfectly</a:t>
-            </a:r>
-            <a:endParaRPr lang="en-US" sz="1800" dirty="0"/>
-          </a:p>
-          <a:p>
-            <a:r>
-              <a:rPr lang="en-US" sz="1800" dirty="0"/>
-              <a:t>Results:</a:t>
-            </a:r>
-          </a:p>
-          <a:p>
-            <a:r>
-              <a:rPr lang="en-US" sz="1800" dirty="0"/>
-              <a:t>Very low training error</a:t>
-            </a:r>
-          </a:p>
-          <a:p>
-            <a:r>
-              <a:rPr lang="en-US" sz="1800" dirty="0"/>
-              <a:t>Very high testing error</a:t>
-            </a:r>
-          </a:p>
-          <a:p>
-            <a:endParaRPr lang="en-US" sz="1800" dirty="0"/>
-          </a:p>
-          <a:p>
-            <a:r>
-              <a:rPr lang="en-US" sz="1800" b="1" dirty="0"/>
-              <a:t>Real-Life Example - Overfitting</a:t>
-            </a:r>
-          </a:p>
-          <a:p>
-            <a:r>
-              <a:rPr lang="en-US" sz="1800" dirty="0"/>
-              <a:t>A student:</a:t>
-            </a:r>
-          </a:p>
-          <a:p>
-            <a:r>
-              <a:rPr lang="en-US" sz="1800" dirty="0"/>
-              <a:t>Memorizes answers instead of understanding concepts</a:t>
-            </a:r>
-          </a:p>
-          <a:p>
-            <a:r>
-              <a:rPr lang="en-US" sz="1800" dirty="0"/>
-              <a:t>Scores 100% in practice tests</a:t>
-            </a:r>
-          </a:p>
-          <a:p>
-            <a:r>
-              <a:rPr lang="en-US" sz="1800" dirty="0"/>
-              <a:t>Fails final exam</a:t>
-            </a:r>
-          </a:p>
-          <a:p>
-            <a:r>
-              <a:rPr lang="en-US" sz="1800" dirty="0"/>
-              <a:t>This is </a:t>
-            </a:r>
-            <a:r>
-              <a:rPr lang="en-US" sz="1800" b="1" dirty="0"/>
-              <a:t>Overfitting</a:t>
-            </a:r>
-            <a:r>
-              <a:rPr lang="en-US" sz="1800" dirty="0"/>
-              <a:t>.</a:t>
-            </a:r>
-          </a:p>
-          <a:p>
-            <a:endParaRPr lang="en-US" sz="1800" dirty="0"/>
-          </a:p>
-        </p:txBody>
-      </p:sp>
-    </p:spTree>
-    <p:extLst>
-      <p:ext uri="{BB962C8B-B14F-4D97-AF65-F5344CB8AC3E}">
-        <p14:creationId xmlns:p14="http://schemas.microsoft.com/office/powerpoint/2010/main" val="793153003"/>
-      </p:ext>
-    </p:extLst>
-  </p:cSld>
-  <p:clrMapOvr>
-    <a:masterClrMapping/>
-  </p:clrMapOvr>
-</p:sld>
-</file>
-
-<file path=ppt/slides/slide16.xml><?xml version="1.0" encoding="utf-8"?>
-<p:sld xmlns:a="http://schemas.openxmlformats.org/drawingml/2006/main" xmlns:r="http://schemas.openxmlformats.org/officeDocument/2006/relationships" xmlns:p="http://schemas.openxmlformats.org/presentationml/2006/main">
-  <p:cSld>
-    <p:spTree>
-      <p:nvGrpSpPr>
-        <p:cNvPr id="1" name=""/>
-        <p:cNvGrpSpPr/>
-        <p:nvPr/>
-      </p:nvGrpSpPr>
-      <p:grpSpPr>
-        <a:xfrm>
-          <a:off x="0" y="0"/>
-          <a:ext cx="0" cy="0"/>
-          <a:chOff x="0" y="0"/>
-          <a:chExt cx="0" cy="0"/>
-        </a:xfrm>
-      </p:grpSpPr>
-      <p:sp>
-        <p:nvSpPr>
-          <p:cNvPr id="2" name="Title 1">
-            <a:extLst>
-              <a:ext uri="{FF2B5EF4-FFF2-40B4-BE49-F238E27FC236}">
                 <a16:creationId xmlns:a16="http://schemas.microsoft.com/office/drawing/2014/main" id="{F135ADCF-C2DF-8DDC-153D-A972BEAB840B}"/>
               </a:ext>
             </a:extLst>
@@ -4697,7 +4567,7 @@
 </p:sld>
 </file>
 
-<file path=ppt/slides/slide17.xml><?xml version="1.0" encoding="utf-8"?>
+<file path=ppt/slides/slide16.xml><?xml version="1.0" encoding="utf-8"?>
 <p:sld xmlns:a="http://schemas.openxmlformats.org/drawingml/2006/main" xmlns:r="http://schemas.openxmlformats.org/officeDocument/2006/relationships" xmlns:p="http://schemas.openxmlformats.org/presentationml/2006/main">
   <p:cSld>
     <p:spTree>

</xml_diff>